<commit_message>
Shrink pptx margin, without clipping line labels
A line's own bbox is just its path, so an arrow's above/below text
labels (drawn as separate floating textboxes, since connectors can't
hold a text_frame) could stick out past it -- margin=0.5in was mostly
compensating for that. Added _content_bbox()/_line_label_rects() so the
slide is sized around what's actually drawn (labels included), then
dropped the default margin to 0.15in now that it only needs to cover
genuine edge effects (stroke width, arrowhead overshoot).

PowerPoint also refuses a slide under 1in on either side, which a small
diagram can now fall under on its own -- _Transform clamps up to that
and centers the diagram in the extra space rather than pinning it to a
corner.

Regenerated examples/pipeline.pptx/.png to match.
</commit_message>
<xml_diff>
--- a/examples/pipeline.pptx
+++ b/examples/pipeline.pptx
@@ -7,7 +7,7 @@
   <p:sldIdLst>
     <p:sldId id="256" r:id="rId7"/>
   </p:sldIdLst>
-  <p:sldSz cx="3591917" cy="2091690" type="screen4x3"/>
+  <p:sldSz cx="2951837" cy="1451610" type="screen4x3"/>
   <p:notesSz cx="6858000" cy="9144000"/>
   <p:defaultTextStyle>
     <a:defPPr>
@@ -3096,7 +3096,7 @@
         </p:nvCxnSpPr>
         <p:spPr>
           <a:xfrm>
-            <a:off x="457200" y="671512"/>
+            <a:off x="137160" y="351472"/>
             <a:ext cx="914400" cy="0"/>
           </a:xfrm>
           <a:prstGeom prst="line">
@@ -3133,7 +3133,7 @@
         </p:nvSpPr>
         <p:spPr>
           <a:xfrm>
-            <a:off x="594360" y="514350"/>
+            <a:off x="274320" y="194310"/>
             <a:ext cx="640080" cy="131445"/>
           </a:xfrm>
           <a:prstGeom prst="rect">
@@ -3168,7 +3168,7 @@
         </p:nvSpPr>
         <p:spPr>
           <a:xfrm>
-            <a:off x="674370" y="697230"/>
+            <a:off x="354330" y="377190"/>
             <a:ext cx="480059" cy="131445"/>
           </a:xfrm>
           <a:prstGeom prst="rect">
@@ -3203,7 +3203,7 @@
         </p:nvSpPr>
         <p:spPr>
           <a:xfrm>
-            <a:off x="1371600" y="457200"/>
+            <a:off x="1051560" y="137160"/>
             <a:ext cx="848717" cy="428625"/>
           </a:xfrm>
           <a:prstGeom prst="roundRect">
@@ -3281,7 +3281,7 @@
         </p:nvCxnSpPr>
         <p:spPr>
           <a:xfrm>
-            <a:off x="2220317" y="671512"/>
+            <a:off x="1900277" y="351472"/>
             <a:ext cx="914400" cy="0"/>
           </a:xfrm>
           <a:prstGeom prst="line">
@@ -3318,7 +3318,7 @@
         </p:nvSpPr>
         <p:spPr>
           <a:xfrm>
-            <a:off x="2357477" y="514350"/>
+            <a:off x="2037437" y="194310"/>
             <a:ext cx="640080" cy="131445"/>
           </a:xfrm>
           <a:prstGeom prst="rect">
@@ -3353,8 +3353,8 @@
         </p:nvSpPr>
         <p:spPr>
           <a:xfrm>
-            <a:off x="2437487" y="697230"/>
-            <a:ext cx="480059" cy="131445"/>
+            <a:off x="2117447" y="377190"/>
+            <a:ext cx="480060" cy="131445"/>
           </a:xfrm>
           <a:prstGeom prst="rect">
             <a:avLst/>
@@ -3388,7 +3388,7 @@
         </p:nvCxnSpPr>
         <p:spPr>
           <a:xfrm>
-            <a:off x="1795958" y="885825"/>
+            <a:off x="1475918" y="565785"/>
             <a:ext cx="0" cy="320040"/>
           </a:xfrm>
           <a:prstGeom prst="line">
@@ -3425,7 +3425,7 @@
         </p:nvSpPr>
         <p:spPr>
           <a:xfrm>
-            <a:off x="1485007" y="1205865"/>
+            <a:off x="1164967" y="885825"/>
             <a:ext cx="621903" cy="428625"/>
           </a:xfrm>
           <a:prstGeom prst="roundRect">

</xml_diff>